<commit_message>
Deck: new app, report, video and repo links; tighten wording on test results
- Slide 6: live app (drishti-indol.vercel.app), project report (Drive),
  YouTube explainer, GitHub repo; report card replaces the 3D-replay link
- Accuracy: 'modelled on' KIET campus, rainfall adapters, replay-test and
  simulated-storm qualifiers, virtual sensors, MOSDAC adapter, API explorer,
  CAP 1.2 export; stable NDMA and Copernicus links
- README, demo script (+PDF), report: new domain and video links
</commit_message>
<xml_diff>
--- a/ppt/Drishti_SIH26085.pptx
+++ b/ppt/Drishti_SIH26085.pptx
@@ -1458,7 +1458,7 @@
           <a:lstStyle/>
           <a:p>
             <a:r>
-              <a:t>Every method in Drishti traces to published work: LISFLOOD-FP and SWMM for hydraulics, STEPS and pysteps for rain nowcasting, U-Net for the surrogate, the Ensemble Kalman Filter for assimilation, and NDMA's urban flooding guidelines for the operational need. Links at the bottom open the live dashboard, the 3D replay, the explainer video and the source code.</a:t>
+              <a:t>Every method in Drishti traces to published work: LISFLOOD-FP and SWMM for hydraulics, STEPS and pysteps for rain nowcasting, U-Net for the surrogate, the Ensemble Kalman Filter for assimilation, and NDMA's urban flooding guidelines for the operational need. Links at the bottom open the live application, the project report, the explainer video and the source code.</a:t>
             </a:r>
           </a:p>
         </p:txBody>
@@ -3784,7 +3784,7 @@
                 <a:latin typeface="Segoe UI"/>
                 <a:cs typeface="Segoe UI"/>
               </a:rPr>
-              <a:t>0–3 h street-level forecasts   •   Physics + AI, not AI alone   •   Piloted on KIET campus, Ghaziabad</a:t>
+              <a:t>0–3 h street-level forecasts   •   Physics + AI, not AI alone   •   Modelled on KIET campus, Ghaziabad</a:t>
             </a:r>
           </a:p>
         </p:txBody>
@@ -4003,7 +4003,7 @@
                 <a:latin typeface="Segoe UI"/>
                 <a:cs typeface="Segoe UI"/>
               </a:rPr>
-              <a:t>Radar, rain gauges,</a:t>
+              <a:t>Radar, gauge and</a:t>
             </a:r>
           </a:p>
           <a:p>
@@ -4020,7 +4020,7 @@
                 <a:latin typeface="Segoe UI"/>
                 <a:cs typeface="Segoe UI"/>
               </a:rPr>
-              <a:t>GPM-IMERG feeds</a:t>
+              <a:t>GPM-IMERG adapters</a:t>
             </a:r>
           </a:p>
         </p:txBody>
@@ -6971,7 +6971,7 @@
                 <a:latin typeface="Segoe UI"/>
                 <a:cs typeface="Segoe UI"/>
               </a:rPr>
-              <a:t>Kalman update cuts sensor-level error from 19.9 cm to 2.7 cm</a:t>
+              <a:t>Kalman update cuts error at 9 virtual sensors from 19.9 cm to 2.7 cm</a:t>
             </a:r>
           </a:p>
         </p:txBody>
@@ -7483,7 +7483,7 @@
                 <a:latin typeface="Segoe UI"/>
                 <a:cs typeface="Segoe UI"/>
               </a:rPr>
-              <a:t>cells warned in time</a:t>
+              <a:t>warned in replay test</a:t>
             </a:r>
           </a:p>
         </p:txBody>
@@ -9892,7 +9892,7 @@
                 <a:latin typeface="Segoe UI"/>
                 <a:cs typeface="Segoe UI"/>
               </a:rPr>
-              <a:t>Radar (MOSDAC)</a:t>
+              <a:t>MOSDAC (adapter)</a:t>
             </a:r>
           </a:p>
         </p:txBody>
@@ -20177,7 +20177,7 @@
                 <a:latin typeface="Segoe UI"/>
                 <a:cs typeface="Segoe UI"/>
               </a:rPr>
-              <a:t>REST API</a:t>
+              <a:t>API EXPLORER</a:t>
             </a:r>
           </a:p>
           <a:p>
@@ -24051,7 +24051,7 @@
                 <a:latin typeface="Segoe UI"/>
                 <a:cs typeface="Segoe UI"/>
               </a:rPr>
-              <a:t>CSI at 10 cm depth, held-out storms</a:t>
+              <a:t>CSI at 10 cm, held-out simulated storms</a:t>
             </a:r>
           </a:p>
         </p:txBody>
@@ -25713,7 +25713,7 @@
                 <a:latin typeface="Segoe UI"/>
                 <a:cs typeface="Segoe UI"/>
               </a:rPr>
-              <a:t>CAP 1.2 · NDMA ALIGNED</a:t>
+              <a:t>CAP 1.2 EXPORT · NDMA GUIDELINES</a:t>
             </a:r>
           </a:p>
         </p:txBody>
@@ -31375,7 +31375,7 @@
                 <a:latin typeface="Segoe UI"/>
                 <a:cs typeface="Segoe UI"/>
               </a:rPr>
-              <a:t>67% OF CELLS WARNED IN TIME</a:t>
+              <a:t>67% WARNED IN TIME (REPLAY)</a:t>
             </a:r>
           </a:p>
         </p:txBody>
@@ -39687,10 +39687,162 @@
           </a:p>
         </p:txBody>
       </p:sp>
+      <p:sp>
+        <p:nvSpPr>
+          <p:cNvPr id="188" name="Rounded Rectangle 187">
+            <a:hlinkClick r:id="rId62"/>
+          </p:cNvPr>
+          <p:cNvSpPr/>
+          <p:nvPr/>
+        </p:nvSpPr>
+        <p:spPr>
+          <a:xfrm>
+            <a:off x="11402568" y="8531352"/>
+            <a:ext cx="2029968" cy="1143000"/>
+          </a:xfrm>
+          <a:prstGeom prst="roundRect">
+            <a:avLst>
+              <a:gd name="adj" fmla="val 6400"/>
+            </a:avLst>
+          </a:prstGeom>
+          <a:solidFill>
+            <a:srgbClr val="EFF6FF"/>
+          </a:solidFill>
+          <a:ln w="15875">
+            <a:solidFill>
+              <a:srgbClr val="2563EB"/>
+            </a:solidFill>
+          </a:ln>
+          <a:effectLst>
+            <a:outerShdw blurRad="76200" dist="25400" dir="5400000" algn="t" rotWithShape="0">
+              <a:srgbClr val="0F172A">
+                <a:alpha val="14000"/>
+              </a:srgbClr>
+            </a:outerShdw>
+          </a:effectLst>
+        </p:spPr>
+        <p:style>
+          <a:lnRef idx="1">
+            <a:schemeClr val="accent1"/>
+          </a:lnRef>
+          <a:fillRef idx="3">
+            <a:schemeClr val="accent1"/>
+          </a:fillRef>
+          <a:effectRef idx="2">
+            <a:schemeClr val="accent1"/>
+          </a:effectRef>
+          <a:fontRef idx="minor">
+            <a:schemeClr val="lt1"/>
+          </a:fontRef>
+        </p:style>
+        <p:txBody>
+          <a:bodyPr rtlCol="0" anchor="ctr" lIns="0" rIns="0" tIns="0" bIns="0"/>
+          <a:lstStyle/>
+          <a:p>
+            <a:pPr algn="ctr"/>
+          </a:p>
+        </p:txBody>
+      </p:sp>
       <p:pic>
         <p:nvPicPr>
-          <p:cNvPr id="188" name="Picture 187" descr="dash_forecast.jpg">
-            <a:hlinkClick r:id="rId63"/>
+          <p:cNvPr id="189" name="Picture 188" descr="file_b.png"/>
+          <p:cNvPicPr>
+            <a:picLocks noChangeAspect="1"/>
+          </p:cNvPicPr>
+          <p:nvPr/>
+        </p:nvPicPr>
+        <p:blipFill>
+          <a:blip r:embed="rId63"/>
+          <a:stretch>
+            <a:fillRect/>
+          </a:stretch>
+        </p:blipFill>
+        <p:spPr>
+          <a:xfrm>
+            <a:off x="12188952" y="8622792"/>
+            <a:ext cx="457200" cy="457200"/>
+          </a:xfrm>
+          <a:prstGeom prst="rect">
+            <a:avLst/>
+          </a:prstGeom>
+        </p:spPr>
+      </p:pic>
+      <p:sp>
+        <p:nvSpPr>
+          <p:cNvPr id="190" name="TextBox 189"/>
+          <p:cNvSpPr txBox="1"/>
+          <p:nvPr/>
+        </p:nvSpPr>
+        <p:spPr>
+          <a:xfrm>
+            <a:off x="11402568" y="9125712"/>
+            <a:ext cx="2029968" cy="228600"/>
+          </a:xfrm>
+          <a:prstGeom prst="rect">
+            <a:avLst/>
+          </a:prstGeom>
+          <a:noFill/>
+        </p:spPr>
+        <p:txBody>
+          <a:bodyPr wrap="square" lIns="0" rIns="0" tIns="0" bIns="0" anchor="t">
+            <a:noAutofit/>
+          </a:bodyPr>
+          <a:lstStyle/>
+          <a:p>
+            <a:pPr algn="ctr"/>
+            <a:r>
+              <a:rPr sz="1050" b="1" i="0" spc="40">
+                <a:solidFill>
+                  <a:srgbClr val="1D4ED8"/>
+                </a:solidFill>
+                <a:latin typeface="Segoe UI"/>
+                <a:cs typeface="Segoe UI"/>
+              </a:rPr>
+              <a:t>PROJECT REPORT  ↗</a:t>
+            </a:r>
+          </a:p>
+        </p:txBody>
+      </p:sp>
+      <p:sp>
+        <p:nvSpPr>
+          <p:cNvPr id="191" name="TextBox 190"/>
+          <p:cNvSpPr txBox="1"/>
+          <p:nvPr/>
+        </p:nvSpPr>
+        <p:spPr>
+          <a:xfrm>
+            <a:off x="11402568" y="9363456"/>
+            <a:ext cx="2029968" cy="228600"/>
+          </a:xfrm>
+          <a:prstGeom prst="rect">
+            <a:avLst/>
+          </a:prstGeom>
+          <a:noFill/>
+        </p:spPr>
+        <p:txBody>
+          <a:bodyPr wrap="square" lIns="0" rIns="0" tIns="0" bIns="0" anchor="t">
+            <a:noAutofit/>
+          </a:bodyPr>
+          <a:lstStyle/>
+          <a:p>
+            <a:pPr algn="ctr"/>
+            <a:r>
+              <a:rPr sz="850" b="0" i="0">
+                <a:solidFill>
+                  <a:srgbClr val="64748B"/>
+                </a:solidFill>
+                <a:latin typeface="Segoe UI"/>
+                <a:cs typeface="Segoe UI"/>
+              </a:rPr>
+              <a:t>Google Drive · full write-up</a:t>
+            </a:r>
+          </a:p>
+        </p:txBody>
+      </p:sp>
+      <p:pic>
+        <p:nvPicPr>
+          <p:cNvPr id="192" name="Picture 191" descr="dash_forecast.jpg">
+            <a:hlinkClick r:id="rId65"/>
           </p:cNvPr>
           <p:cNvPicPr>
             <a:picLocks noChangeAspect="1"/>
@@ -39698,7 +39850,7 @@
           <p:nvPr/>
         </p:nvPicPr>
         <p:blipFill>
-          <a:blip r:embed="rId62"/>
+          <a:blip r:embed="rId64"/>
           <a:stretch>
             <a:fillRect/>
           </a:stretch>
@@ -39729,8 +39881,8 @@
       </p:pic>
       <p:sp>
         <p:nvSpPr>
-          <p:cNvPr id="189" name="Rectangle 188">
-            <a:hlinkClick r:id="rId63"/>
+          <p:cNvPr id="193" name="Rectangle 192">
+            <a:hlinkClick r:id="rId65"/>
           </p:cNvPr>
           <p:cNvSpPr/>
           <p:nvPr/>
@@ -39782,15 +39934,15 @@
                 <a:latin typeface="Segoe UI"/>
                 <a:cs typeface="Segoe UI"/>
               </a:rPr>
-              <a:t>LIVE DASHBOARD  ↗</a:t>
+              <a:t>LIVE APPLICATION  ↗</a:t>
             </a:r>
           </a:p>
         </p:txBody>
       </p:sp>
       <p:pic>
         <p:nvPicPr>
-          <p:cNvPr id="190" name="Picture 189" descr="home.jpg">
-            <a:hlinkClick r:id="rId65"/>
+          <p:cNvPr id="194" name="Picture 193" descr="drishti_explainer.jpg">
+            <a:hlinkClick r:id="rId67"/>
           </p:cNvPr>
           <p:cNvPicPr>
             <a:picLocks noChangeAspect="1"/>
@@ -39798,14 +39950,14 @@
           <p:nvPr/>
         </p:nvPicPr>
         <p:blipFill>
-          <a:blip r:embed="rId64"/>
+          <a:blip r:embed="rId66"/>
           <a:stretch>
             <a:fillRect/>
           </a:stretch>
         </p:blipFill>
         <p:spPr>
           <a:xfrm>
-            <a:off x="11402568" y="8531352"/>
+            <a:off x="13542264" y="8531352"/>
             <a:ext cx="2029968" cy="1143000"/>
           </a:xfrm>
           <a:prstGeom prst="roundRect">
@@ -39829,15 +39981,15 @@
       </p:pic>
       <p:sp>
         <p:nvSpPr>
-          <p:cNvPr id="191" name="Rectangle 190">
-            <a:hlinkClick r:id="rId65"/>
+          <p:cNvPr id="195" name="Rectangle 194">
+            <a:hlinkClick r:id="rId67"/>
           </p:cNvPr>
           <p:cNvSpPr/>
           <p:nvPr/>
         </p:nvSpPr>
         <p:spPr>
           <a:xfrm>
-            <a:off x="11402568" y="9418320"/>
+            <a:off x="13542264" y="9418320"/>
             <a:ext cx="2029968" cy="256032"/>
           </a:xfrm>
           <a:prstGeom prst="rect">
@@ -39882,106 +40034,6 @@
                 <a:latin typeface="Segoe UI"/>
                 <a:cs typeface="Segoe UI"/>
               </a:rPr>
-              <a:t>3D STORM REPLAY  ↗</a:t>
-            </a:r>
-          </a:p>
-        </p:txBody>
-      </p:sp>
-      <p:pic>
-        <p:nvPicPr>
-          <p:cNvPr id="192" name="Picture 191" descr="brag.jpg">
-            <a:hlinkClick r:id="rId67"/>
-          </p:cNvPr>
-          <p:cNvPicPr>
-            <a:picLocks noChangeAspect="1"/>
-          </p:cNvPicPr>
-          <p:nvPr/>
-        </p:nvPicPr>
-        <p:blipFill>
-          <a:blip r:embed="rId66"/>
-          <a:stretch>
-            <a:fillRect/>
-          </a:stretch>
-        </p:blipFill>
-        <p:spPr>
-          <a:xfrm>
-            <a:off x="13542264" y="8531352"/>
-            <a:ext cx="2029968" cy="1143000"/>
-          </a:xfrm>
-          <a:prstGeom prst="roundRect">
-            <a:avLst>
-              <a:gd name="adj" fmla="val 6400"/>
-            </a:avLst>
-          </a:prstGeom>
-          <a:ln w="12700">
-            <a:solidFill>
-              <a:srgbClr val="CBD5E1"/>
-            </a:solidFill>
-          </a:ln>
-          <a:effectLst>
-            <a:outerShdw blurRad="127000" dist="38100" dir="5400000" algn="t" rotWithShape="0">
-              <a:srgbClr val="0F172A">
-                <a:alpha val="22000"/>
-              </a:srgbClr>
-            </a:outerShdw>
-          </a:effectLst>
-        </p:spPr>
-      </p:pic>
-      <p:sp>
-        <p:nvSpPr>
-          <p:cNvPr id="193" name="Rectangle 192">
-            <a:hlinkClick r:id="rId67"/>
-          </p:cNvPr>
-          <p:cNvSpPr/>
-          <p:nvPr/>
-        </p:nvSpPr>
-        <p:spPr>
-          <a:xfrm>
-            <a:off x="13542264" y="9418320"/>
-            <a:ext cx="2029968" cy="256032"/>
-          </a:xfrm>
-          <a:prstGeom prst="rect">
-            <a:avLst/>
-          </a:prstGeom>
-          <a:solidFill>
-            <a:srgbClr val="0B0D11">
-              <a:alpha val="78000"/>
-            </a:srgbClr>
-          </a:solidFill>
-          <a:ln>
-            <a:noFill/>
-          </a:ln>
-          <a:effectLst/>
-        </p:spPr>
-        <p:style>
-          <a:lnRef idx="1">
-            <a:schemeClr val="accent1"/>
-          </a:lnRef>
-          <a:fillRef idx="3">
-            <a:schemeClr val="accent1"/>
-          </a:fillRef>
-          <a:effectRef idx="2">
-            <a:schemeClr val="accent1"/>
-          </a:effectRef>
-          <a:fontRef idx="minor">
-            <a:schemeClr val="lt1"/>
-          </a:fontRef>
-        </p:style>
-        <p:txBody>
-          <a:bodyPr rtlCol="0" anchor="ctr" lIns="0" rIns="0" tIns="0" bIns="0" wrap="square">
-            <a:noAutofit/>
-          </a:bodyPr>
-          <a:lstStyle/>
-          <a:p>
-            <a:pPr algn="ctr"/>
-            <a:r>
-              <a:rPr sz="950" b="1" i="0" spc="40">
-                <a:solidFill>
-                  <a:srgbClr val="FFFFFF"/>
-                </a:solidFill>
-                <a:latin typeface="Segoe UI"/>
-                <a:cs typeface="Segoe UI"/>
-              </a:rPr>
               <a:t>EXPLAINER VIDEO  ↗</a:t>
             </a:r>
           </a:p>
@@ -39989,7 +40041,7 @@
       </p:sp>
       <p:sp>
         <p:nvSpPr>
-          <p:cNvPr id="194" name="Oval 193"/>
+          <p:cNvPr id="196" name="Oval 195"/>
           <p:cNvSpPr/>
           <p:nvPr/>
         </p:nvSpPr>
@@ -40035,7 +40087,7 @@
       </p:sp>
       <p:pic>
         <p:nvPicPr>
-          <p:cNvPr id="195" name="Picture 194" descr="play_w.png"/>
+          <p:cNvPr id="197" name="Picture 196" descr="play_w.png"/>
           <p:cNvPicPr>
             <a:picLocks noChangeAspect="1"/>
           </p:cNvPicPr>
@@ -40059,7 +40111,7 @@
       </p:pic>
       <p:sp>
         <p:nvSpPr>
-          <p:cNvPr id="196" name="Rounded Rectangle 195">
+          <p:cNvPr id="198" name="Rounded Rectangle 197">
             <a:hlinkClick r:id="rId69"/>
           </p:cNvPr>
           <p:cNvSpPr/>
@@ -40113,7 +40165,7 @@
       </p:sp>
       <p:pic>
         <p:nvPicPr>
-          <p:cNvPr id="197" name="Picture 196" descr="github_w.png"/>
+          <p:cNvPr id="199" name="Picture 198" descr="github_w.png"/>
           <p:cNvPicPr>
             <a:picLocks noChangeAspect="1"/>
           </p:cNvPicPr>
@@ -40137,7 +40189,7 @@
       </p:pic>
       <p:sp>
         <p:nvSpPr>
-          <p:cNvPr id="198" name="TextBox 197"/>
+          <p:cNvPr id="200" name="TextBox 199"/>
           <p:cNvSpPr txBox="1"/>
           <p:nvPr/>
         </p:nvSpPr>
@@ -40173,7 +40225,7 @@
       </p:sp>
       <p:sp>
         <p:nvSpPr>
-          <p:cNvPr id="199" name="TextBox 198"/>
+          <p:cNvPr id="201" name="TextBox 200"/>
           <p:cNvSpPr txBox="1"/>
           <p:nvPr/>
         </p:nvSpPr>
@@ -40202,7 +40254,7 @@
                 <a:latin typeface="Segoe UI"/>
                 <a:cs typeface="Segoe UI"/>
               </a:rPr>
-              <a:t>github.com/arpitpandey0307</a:t>
+              <a:t>github.com/arpitpandey0307/Drishti</a:t>
             </a:r>
           </a:p>
         </p:txBody>

</xml_diff>